<commit_message>
Update repo for July 2026 delivery
</commit_message>
<xml_diff>
--- a/warner-ab900.pptx
+++ b/warner-ab900.pptx
@@ -8161,6 +8161,10 @@
           </a:solidFill>
           <a:ln/>
         </p:spPr>
+        <p:txBody>
+          <a:bodyPr/>
+          <a:p/>
+        </p:txBody>
       </p:sp>
       <p:sp>
         <p:nvSpPr>
@@ -8195,7 +8199,7 @@
                 <a:ea typeface="Arial" pitchFamily="34" charset="-122"/>
                 <a:cs typeface="Arial" pitchFamily="34" charset="-120"/>
               </a:rPr>
-              <a:t>Copilot Studio: Lite vs. Full Experience</a:t>
+              <a:t>Agent Builder vs. Copilot Studio</a:t>
             </a:r>
             <a:endParaRPr lang="en-US" sz="2400" dirty="0"/>
           </a:p>
@@ -8220,6 +8224,10 @@
           </a:solidFill>
           <a:ln/>
         </p:spPr>
+        <p:txBody>
+          <a:bodyPr/>
+          <a:p/>
+        </p:txBody>
       </p:sp>
       <p:sp>
         <p:nvSpPr>
@@ -8337,7 +8345,7 @@
                 <a:ea typeface="Arial" pitchFamily="34" charset="-122"/>
                 <a:cs typeface="Arial" pitchFamily="34" charset="-120"/>
               </a:rPr>
-              <a:t>Lite Experience (Testable!)</a:t>
+              <a:t>Agent Builder (Testable!)</a:t>
             </a:r>
             <a:endParaRPr lang="en-US" sz="1400" dirty="0"/>
           </a:p>
@@ -8513,7 +8521,7 @@
                 <a:ea typeface="Arial" pitchFamily="34" charset="-122"/>
                 <a:cs typeface="Arial" pitchFamily="34" charset="-120"/>
               </a:rPr>
-              <a:t>Full Experience</a:t>
+              <a:t>Copilot Studio (Full)</a:t>
             </a:r>
             <a:endParaRPr lang="en-US" sz="1400" dirty="0"/>
           </a:p>
@@ -8670,6 +8678,10 @@
           </a:solidFill>
           <a:ln/>
         </p:spPr>
+        <p:txBody>
+          <a:bodyPr/>
+          <a:p/>
+        </p:txBody>
       </p:sp>
     </p:spTree>
   </p:cSld>
@@ -8722,6 +8734,10 @@
           </a:solidFill>
           <a:ln/>
         </p:spPr>
+        <p:txBody>
+          <a:bodyPr/>
+          <a:p/>
+        </p:txBody>
       </p:sp>
       <p:sp>
         <p:nvSpPr>
@@ -8756,7 +8772,7 @@
                 <a:ea typeface="Arial" pitchFamily="34" charset="-122"/>
                 <a:cs typeface="Arial" pitchFamily="34" charset="-120"/>
               </a:rPr>
-              <a:t>Creating a Copilot Chat Agent</a:t>
+              <a:t>Creating an Agent in Agent Builder</a:t>
             </a:r>
             <a:endParaRPr lang="en-US" sz="2400" dirty="0"/>
           </a:p>
@@ -8781,6 +8797,10 @@
           </a:solidFill>
           <a:ln/>
         </p:spPr>
+        <p:txBody>
+          <a:bodyPr/>
+          <a:p/>
+        </p:txBody>
       </p:sp>
       <p:sp>
         <p:nvSpPr>
@@ -8886,7 +8906,7 @@
                 <a:ea typeface="Arial" pitchFamily="34" charset="-122"/>
                 <a:cs typeface="Arial" pitchFamily="34" charset="-120"/>
               </a:rPr>
-              <a:t>Enter description in natural language; Copilot Studio refines via follow-up questions</a:t>
+              <a:t>Enter description in natural language; Agent Builder refines via follow-up questions</a:t>
             </a:r>
             <a:endParaRPr lang="en-US" sz="1500" dirty="0"/>
           </a:p>
@@ -8963,7 +8983,7 @@
                 <a:ea typeface="Arial" pitchFamily="34" charset="-122"/>
                 <a:cs typeface="Arial" pitchFamily="34" charset="-120"/>
               </a:rPr>
-              <a:t>Capabilities (off by default): Code Interpreter, Image Generator</a:t>
+              <a:t>Capabilities (ON by default): Code interpreter, Image generator</a:t>
             </a:r>
             <a:endParaRPr lang="en-US" sz="1500" dirty="0"/>
           </a:p>
@@ -8985,7 +9005,7 @@
                 <a:ea typeface="Arial" pitchFamily="34" charset="-122"/>
                 <a:cs typeface="Arial" pitchFamily="34" charset="-120"/>
               </a:rPr>
-              <a:t>Starter prompts: unlimited for Copilot Chat agents</a:t>
+              <a:t>Starter prompts: no documented minimum or maximum</a:t>
             </a:r>
             <a:endParaRPr lang="en-US" sz="1500" dirty="0"/>
           </a:p>
@@ -10803,6 +10823,10 @@
           </a:solidFill>
           <a:ln/>
         </p:spPr>
+        <p:txBody>
+          <a:bodyPr/>
+          <a:p/>
+        </p:txBody>
       </p:sp>
       <p:sp>
         <p:nvSpPr>
@@ -10943,7 +10967,7 @@
                 <a:ea typeface="Arial" pitchFamily="34" charset="-122"/>
                 <a:cs typeface="Arial" pitchFamily="34" charset="-120"/>
               </a:rPr>
-              <a:t>6. Show the agent approval queue at admin.microsoft.com &gt; Copilot &gt; Agents</a:t>
+              <a:t>6. Show the agent approval queue at admin.microsoft.com &gt; Agents &gt; All agents &gt; Requests</a:t>
             </a:r>
             <a:endParaRPr lang="en-US" sz="1500" dirty="0"/>
           </a:p>
@@ -11332,6 +11356,10 @@
           </a:solidFill>
           <a:ln/>
         </p:spPr>
+        <p:txBody>
+          <a:bodyPr/>
+          <a:p/>
+        </p:txBody>
       </p:sp>
       <p:sp>
         <p:nvSpPr>
@@ -11391,6 +11419,10 @@
           </a:solidFill>
           <a:ln/>
         </p:spPr>
+        <p:txBody>
+          <a:bodyPr/>
+          <a:p/>
+        </p:txBody>
       </p:sp>
       <p:sp>
         <p:nvSpPr>
@@ -11430,7 +11462,7 @@
                 <a:ea typeface="Arial" pitchFamily="34" charset="-122"/>
                 <a:cs typeface="Arial" pitchFamily="34" charset="-120"/>
               </a:rPr>
-              <a:t>purview.microsoft.com -- NOT compliance.microsoft.com (deprecated)</a:t>
+              <a:t>purview.microsoft.com -- NOT compliance.microsoft.com (retired)</a:t>
             </a:r>
             <a:endParaRPr lang="en-US" sz="1500" dirty="0"/>
           </a:p>
@@ -12753,6 +12785,10 @@
           </a:solidFill>
           <a:ln/>
         </p:spPr>
+        <p:txBody>
+          <a:bodyPr/>
+          <a:p/>
+        </p:txBody>
       </p:sp>
       <p:sp>
         <p:nvSpPr>
@@ -12812,6 +12848,10 @@
           </a:solidFill>
           <a:ln/>
         </p:spPr>
+        <p:txBody>
+          <a:bodyPr/>
+          <a:p/>
+        </p:txBody>
       </p:sp>
       <p:sp>
         <p:nvSpPr>
@@ -13005,7 +13045,7 @@
                 <a:ea typeface="Arial" pitchFamily="34" charset="-122"/>
                 <a:cs typeface="Arial" pitchFamily="34" charset="-120"/>
               </a:rPr>
-              <a:t>EXAM TRAP: Use DSPM for AI (not Content Explorer) for AI-specific data risk</a:t>
+              <a:t>EXAM TRAP: Use DSPM for AI (not Data Explorer) for AI-specific data risk</a:t>
             </a:r>
             <a:endParaRPr lang="en-US" sz="1500" dirty="0"/>
           </a:p>
@@ -13027,7 +13067,7 @@
                 <a:ea typeface="Arial" pitchFamily="34" charset="-122"/>
                 <a:cs typeface="Arial" pitchFamily="34" charset="-120"/>
               </a:rPr>
-              <a:t>Content Explorer finds sensitive data. DSPM for AI monitors AI interactions.</a:t>
+              <a:t>Data Explorer finds sensitive data. DSPM for AI monitors AI interactions.</a:t>
             </a:r>
             <a:endParaRPr lang="en-US" sz="1500" dirty="0"/>
           </a:p>
@@ -13084,6 +13124,10 @@
           </a:solidFill>
           <a:ln/>
         </p:spPr>
+        <p:txBody>
+          <a:bodyPr/>
+          <a:p/>
+        </p:txBody>
       </p:sp>
       <p:sp>
         <p:nvSpPr>
@@ -13143,6 +13187,10 @@
           </a:solidFill>
           <a:ln/>
         </p:spPr>
+        <p:txBody>
+          <a:bodyPr/>
+          <a:p/>
+        </p:txBody>
       </p:sp>
       <p:sp>
         <p:nvSpPr>
@@ -13281,7 +13329,7 @@
                 <a:ea typeface="Arial" pitchFamily="34" charset="-122"/>
                 <a:cs typeface="Arial" pitchFamily="34" charset="-120"/>
               </a:rPr>
-              <a:t>Standard: search + export + legal hold</a:t>
+              <a:t>ONE unified eDiscovery -- classic Standard/Premium retired Aug 2025</a:t>
             </a:r>
             <a:endParaRPr lang="en-US" sz="1500" dirty="0"/>
           </a:p>
@@ -13303,7 +13351,7 @@
                 <a:ea typeface="Arial" pitchFamily="34" charset="-122"/>
                 <a:cs typeface="Arial" pitchFamily="34" charset="-120"/>
               </a:rPr>
-              <a:t>Premium: case management + analytics + redaction</a:t>
+              <a:t>Premium FEATURES (by subscription): analytics, redaction, review sets</a:t>
             </a:r>
             <a:endParaRPr lang="en-US" sz="1500" dirty="0"/>
           </a:p>
@@ -14022,6 +14070,10 @@
           </a:solidFill>
           <a:ln/>
         </p:spPr>
+        <p:txBody>
+          <a:bodyPr/>
+          <a:p/>
+        </p:txBody>
       </p:sp>
       <p:sp>
         <p:nvSpPr>
@@ -14081,6 +14133,10 @@
           </a:solidFill>
           <a:ln/>
         </p:spPr>
+        <p:txBody>
+          <a:bodyPr/>
+          <a:p/>
+        </p:txBody>
       </p:sp>
       <p:sp>
         <p:nvSpPr>
@@ -14263,7 +14319,7 @@
                 <a:ea typeface="Arial" pitchFamily="34" charset="-122"/>
                 <a:cs typeface="Arial" pitchFamily="34" charset="-120"/>
               </a:rPr>
-              <a:t>SharePoint Advanced Management (SAM) -- paid add-on for restricted site access</a:t>
+              <a:t>SharePoint Advanced Management (SAM) -- add-on for restricted access control (RAC)</a:t>
             </a:r>
             <a:endParaRPr lang="en-US" sz="1500" dirty="0"/>
           </a:p>
@@ -19651,6 +19707,10 @@
           </a:solidFill>
           <a:ln/>
         </p:spPr>
+        <p:txBody>
+          <a:bodyPr/>
+          <a:p/>
+        </p:txBody>
       </p:sp>
       <p:sp>
         <p:nvSpPr>
@@ -19710,6 +19770,10 @@
           </a:solidFill>
           <a:ln/>
         </p:spPr>
+        <p:txBody>
+          <a:bodyPr/>
+          <a:p/>
+        </p:txBody>
       </p:sp>
       <p:sp>
         <p:nvSpPr>
@@ -19903,7 +19967,7 @@
                 <a:ea typeface="Arial" pitchFamily="34" charset="-122"/>
                 <a:cs typeface="Arial" pitchFamily="34" charset="-120"/>
               </a:rPr>
-              <a:t>DSPM for AI for AI-specific risk; Content Explorer for general sensitive data</a:t>
+              <a:t>DSPM for AI for AI-specific risk; Data Explorer for general sensitive data</a:t>
             </a:r>
             <a:endParaRPr lang="en-US" sz="1500" dirty="0"/>
           </a:p>
@@ -20475,6 +20539,10 @@
           </a:solidFill>
           <a:ln/>
         </p:spPr>
+        <p:txBody>
+          <a:bodyPr/>
+          <a:p/>
+        </p:txBody>
       </p:sp>
       <p:sp>
         <p:nvSpPr>
@@ -20534,6 +20602,10 @@
           </a:solidFill>
           <a:ln/>
         </p:spPr>
+        <p:txBody>
+          <a:bodyPr/>
+          <a:p/>
+        </p:txBody>
       </p:sp>
       <p:sp>
         <p:nvSpPr>
@@ -20595,7 +20667,7 @@
                 <a:ea typeface="Arial" pitchFamily="34" charset="-122"/>
                 <a:cs typeface="Arial" pitchFamily="34" charset="-120"/>
               </a:rPr>
-              <a:t>Work IQ -- intelligence layer that learns patterns and workflows</a:t>
+              <a:t>Work IQ -- intelligence layer that CONTAINS Graph and the semantic index</a:t>
             </a:r>
             <a:endParaRPr lang="en-US" sz="1500" dirty="0"/>
           </a:p>
@@ -20617,7 +20689,7 @@
                 <a:ea typeface="Arial" pitchFamily="34" charset="-122"/>
                 <a:cs typeface="Arial" pitchFamily="34" charset="-120"/>
               </a:rPr>
-              <a:t>Large Language Models -- hosted in Azure OpenAI, fine-tuned for enterprise</a:t>
+              <a:t>Large Language Models -- multi-provider foundation models, enterprise-tuned</a:t>
             </a:r>
             <a:endParaRPr lang="en-US" sz="1500" dirty="0"/>
           </a:p>
@@ -21554,6 +21626,10 @@
           </a:solidFill>
           <a:ln/>
         </p:spPr>
+        <p:txBody>
+          <a:bodyPr/>
+          <a:p/>
+        </p:txBody>
       </p:sp>
       <p:sp>
         <p:nvSpPr>
@@ -21613,6 +21689,10 @@
           </a:solidFill>
           <a:ln/>
         </p:spPr>
+        <p:txBody>
+          <a:bodyPr/>
+          <a:p/>
+        </p:txBody>
       </p:sp>
       <p:graphicFrame>
         <p:nvGraphicFramePr>
@@ -22139,7 +22219,7 @@
                           <a:ea typeface="Arial" pitchFamily="34" charset="-122"/>
                           <a:cs typeface="Arial" pitchFamily="34" charset="-120"/>
                         </a:rPr>
-                        <a:t>Up to 300 users</a:t>
+                        <a:t>300-seat MAXIMUM</a:t>
                       </a:r>
                       <a:endParaRPr lang="en-US" sz="1200" dirty="0">
                         <a:latin typeface="Arial" charset="0"/>

</xml_diff>